<commit_message>
Actualizar portada y monetizacion: remover roles internos, url privada app y precios especificos
</commit_message>
<xml_diff>
--- a/presentacion_crocscale_ia.pptx
+++ b/presentacion_crocscale_ia.pptx
@@ -3323,7 +3323,7 @@
                 </a:solidFill>
                 <a:latin typeface="Segoe UI"/>
               </a:rPr>
-              <a:t>Nicolás Marcelo Galarza Vázquez (AI Automation Architect &amp; Founder)</a:t>
+              <a:t>Nicolás Marcelo Galarza Vázquez</a:t>
             </a:r>
           </a:p>
           <a:p>
@@ -3448,7 +3448,7 @@
                 </a:solidFill>
                 <a:latin typeface="Segoe UI"/>
               </a:rPr>
-              <a:t>https://crocscale.com | https://app.crocscale.com</a:t>
+              <a:t>https://crocscale.com</a:t>
             </a:r>
           </a:p>
         </p:txBody>
@@ -3813,7 +3813,7 @@
                 </a:solidFill>
                 <a:latin typeface="Segoe UI"/>
               </a:rPr>
-              <a:t>Planes mensuales escalonados (WA Starter $269, Omnicanal Direct $399, Pro $555) y Meta Ads.</a:t>
+              <a:t>Planes mensuales escalonados según volumen y canales, y gestión estratégica de Meta Ads.</a:t>
             </a:r>
           </a:p>
         </p:txBody>

</xml_diff>